<commit_message>
meilleir design de la piste de Garde
</commit_message>
<xml_diff>
--- a/pictures/Quartiers-de-Garde-fr/Quartiers-de-Garde-fr.pptx
+++ b/pictures/Quartiers-de-Garde-fr/Quartiers-de-Garde-fr.pptx
@@ -199,7 +199,7 @@
           <a:p>
             <a:fld id="{263B0988-6DB9-4E3D-B7FD-EFF3BCABE954}" type="datetimeFigureOut">
               <a:rPr lang="fr-FR" smtClean="0"/>
-              <a:t>28/09/2026</a:t>
+              <a:t>29/09/2026</a:t>
             </a:fld>
             <a:endParaRPr lang="fr-FR"/>
           </a:p>
@@ -805,7 +805,7 @@
           <a:p>
             <a:fld id="{588505E2-0C4C-443F-8F57-41958F504CA2}" type="datetimeFigureOut">
               <a:rPr lang="fr-FR" smtClean="0"/>
-              <a:t>28/09/2026</a:t>
+              <a:t>29/09/2026</a:t>
             </a:fld>
             <a:endParaRPr lang="fr-FR"/>
           </a:p>
@@ -1003,7 +1003,7 @@
           <a:p>
             <a:fld id="{588505E2-0C4C-443F-8F57-41958F504CA2}" type="datetimeFigureOut">
               <a:rPr lang="fr-FR" smtClean="0"/>
-              <a:t>28/09/2026</a:t>
+              <a:t>29/09/2026</a:t>
             </a:fld>
             <a:endParaRPr lang="fr-FR"/>
           </a:p>
@@ -1211,7 +1211,7 @@
           <a:p>
             <a:fld id="{588505E2-0C4C-443F-8F57-41958F504CA2}" type="datetimeFigureOut">
               <a:rPr lang="fr-FR" smtClean="0"/>
-              <a:t>28/09/2026</a:t>
+              <a:t>29/09/2026</a:t>
             </a:fld>
             <a:endParaRPr lang="fr-FR"/>
           </a:p>
@@ -1409,7 +1409,7 @@
           <a:p>
             <a:fld id="{588505E2-0C4C-443F-8F57-41958F504CA2}" type="datetimeFigureOut">
               <a:rPr lang="fr-FR" smtClean="0"/>
-              <a:t>28/09/2026</a:t>
+              <a:t>29/09/2026</a:t>
             </a:fld>
             <a:endParaRPr lang="fr-FR"/>
           </a:p>
@@ -1684,7 +1684,7 @@
           <a:p>
             <a:fld id="{588505E2-0C4C-443F-8F57-41958F504CA2}" type="datetimeFigureOut">
               <a:rPr lang="fr-FR" smtClean="0"/>
-              <a:t>28/09/2026</a:t>
+              <a:t>29/09/2026</a:t>
             </a:fld>
             <a:endParaRPr lang="fr-FR"/>
           </a:p>
@@ -1949,7 +1949,7 @@
           <a:p>
             <a:fld id="{588505E2-0C4C-443F-8F57-41958F504CA2}" type="datetimeFigureOut">
               <a:rPr lang="fr-FR" smtClean="0"/>
-              <a:t>28/09/2026</a:t>
+              <a:t>29/09/2026</a:t>
             </a:fld>
             <a:endParaRPr lang="fr-FR"/>
           </a:p>
@@ -2361,7 +2361,7 @@
           <a:p>
             <a:fld id="{588505E2-0C4C-443F-8F57-41958F504CA2}" type="datetimeFigureOut">
               <a:rPr lang="fr-FR" smtClean="0"/>
-              <a:t>28/09/2026</a:t>
+              <a:t>29/09/2026</a:t>
             </a:fld>
             <a:endParaRPr lang="fr-FR"/>
           </a:p>
@@ -2502,7 +2502,7 @@
           <a:p>
             <a:fld id="{588505E2-0C4C-443F-8F57-41958F504CA2}" type="datetimeFigureOut">
               <a:rPr lang="fr-FR" smtClean="0"/>
-              <a:t>28/09/2026</a:t>
+              <a:t>29/09/2026</a:t>
             </a:fld>
             <a:endParaRPr lang="fr-FR"/>
           </a:p>
@@ -2615,7 +2615,7 @@
           <a:p>
             <a:fld id="{588505E2-0C4C-443F-8F57-41958F504CA2}" type="datetimeFigureOut">
               <a:rPr lang="fr-FR" smtClean="0"/>
-              <a:t>28/09/2026</a:t>
+              <a:t>29/09/2026</a:t>
             </a:fld>
             <a:endParaRPr lang="fr-FR"/>
           </a:p>
@@ -2926,7 +2926,7 @@
           <a:p>
             <a:fld id="{588505E2-0C4C-443F-8F57-41958F504CA2}" type="datetimeFigureOut">
               <a:rPr lang="fr-FR" smtClean="0"/>
-              <a:t>28/09/2026</a:t>
+              <a:t>29/09/2026</a:t>
             </a:fld>
             <a:endParaRPr lang="fr-FR"/>
           </a:p>
@@ -3214,7 +3214,7 @@
           <a:p>
             <a:fld id="{588505E2-0C4C-443F-8F57-41958F504CA2}" type="datetimeFigureOut">
               <a:rPr lang="fr-FR" smtClean="0"/>
-              <a:t>28/09/2026</a:t>
+              <a:t>29/09/2026</a:t>
             </a:fld>
             <a:endParaRPr lang="fr-FR"/>
           </a:p>
@@ -3455,7 +3455,7 @@
           <a:p>
             <a:fld id="{588505E2-0C4C-443F-8F57-41958F504CA2}" type="datetimeFigureOut">
               <a:rPr lang="fr-FR" smtClean="0"/>
-              <a:t>28/09/2026</a:t>
+              <a:t>29/09/2026</a:t>
             </a:fld>
             <a:endParaRPr lang="fr-FR"/>
           </a:p>
@@ -9162,10 +9162,10 @@
       </p:grpSpPr>
       <p:grpSp>
         <p:nvGrpSpPr>
-          <p:cNvPr id="7" name="Groupe 6">
+          <p:cNvPr id="79" name="Groupe 78">
             <a:extLst>
               <a:ext uri="{FF2B5EF4-FFF2-40B4-BE49-F238E27FC236}">
-                <a16:creationId xmlns:a16="http://schemas.microsoft.com/office/drawing/2014/main" id="{E61CFC11-50B4-DC2A-9A7E-44FCA429B702}"/>
+                <a16:creationId xmlns:a16="http://schemas.microsoft.com/office/drawing/2014/main" id="{8BC1BA6F-AB29-01E9-5ED5-E2DC36881F16}"/>
               </a:ext>
             </a:extLst>
           </p:cNvPr>
@@ -9174,9 +9174,9 @@
         </p:nvGrpSpPr>
         <p:grpSpPr>
           <a:xfrm>
-            <a:off x="2148840" y="932688"/>
+            <a:off x="1469390" y="855218"/>
             <a:ext cx="4498848" cy="3420000"/>
-            <a:chOff x="2148840" y="932688"/>
+            <a:chOff x="1469390" y="855218"/>
             <a:chExt cx="4498848" cy="3420000"/>
           </a:xfrm>
         </p:grpSpPr>
@@ -9194,26 +9194,14 @@
           </p:nvSpPr>
           <p:spPr>
             <a:xfrm>
-              <a:off x="2148840" y="932688"/>
+              <a:off x="1469390" y="855218"/>
               <a:ext cx="4498848" cy="3420000"/>
             </a:xfrm>
             <a:prstGeom prst="rect">
               <a:avLst/>
             </a:prstGeom>
             <a:blipFill>
-              <a:blip r:embed="rId3">
-                <a:extLst>
-                  <a:ext uri="{BEBA8EAE-BF5A-486C-A8C5-ECC9F3942E4B}">
-                    <a14:imgProps xmlns:a14="http://schemas.microsoft.com/office/drawing/2010/main">
-                      <a14:imgLayer r:embed="rId4">
-                        <a14:imgEffect>
-                          <a14:brightnessContrast bright="20000" contrast="-40000"/>
-                        </a14:imgEffect>
-                      </a14:imgLayer>
-                    </a14:imgProps>
-                  </a:ext>
-                </a:extLst>
-              </a:blip>
+              <a:blip r:embed="rId3"/>
               <a:tile tx="0" ty="0" sx="100000" sy="100000" flip="none" algn="tl"/>
             </a:blipFill>
             <a:ln w="9525">
@@ -9272,14 +9260,14 @@
           </p:nvSpPr>
           <p:spPr>
             <a:xfrm>
-              <a:off x="2378071" y="1152218"/>
+              <a:off x="1698621" y="1074748"/>
               <a:ext cx="900000" cy="900000"/>
             </a:xfrm>
             <a:prstGeom prst="rect">
               <a:avLst/>
             </a:prstGeom>
             <a:blipFill>
-              <a:blip r:embed="rId5">
+              <a:blip r:embed="rId4">
                 <a:duotone>
                   <a:schemeClr val="bg2">
                     <a:shade val="45000"/>
@@ -9290,7 +9278,7 @@
                 <a:extLst>
                   <a:ext uri="{BEBA8EAE-BF5A-486C-A8C5-ECC9F3942E4B}">
                     <a14:imgProps xmlns:a14="http://schemas.microsoft.com/office/drawing/2010/main">
-                      <a14:imgLayer r:embed="rId6">
+                      <a14:imgLayer r:embed="rId5">
                         <a14:imgEffect>
                           <a14:artisticWatercolorSponge/>
                         </a14:imgEffect>
@@ -9380,14 +9368,14 @@
           </p:nvSpPr>
           <p:spPr>
             <a:xfrm>
-              <a:off x="3416015" y="1152218"/>
+              <a:off x="2736565" y="1074748"/>
               <a:ext cx="900000" cy="900000"/>
             </a:xfrm>
             <a:prstGeom prst="rect">
               <a:avLst/>
             </a:prstGeom>
             <a:blipFill>
-              <a:blip r:embed="rId5">
+              <a:blip r:embed="rId4">
                 <a:duotone>
                   <a:schemeClr val="bg2">
                     <a:shade val="45000"/>
@@ -9398,7 +9386,7 @@
                 <a:extLst>
                   <a:ext uri="{BEBA8EAE-BF5A-486C-A8C5-ECC9F3942E4B}">
                     <a14:imgProps xmlns:a14="http://schemas.microsoft.com/office/drawing/2010/main">
-                      <a14:imgLayer r:embed="rId6">
+                      <a14:imgLayer r:embed="rId5">
                         <a14:imgEffect>
                           <a14:artisticWatercolorSponge/>
                         </a14:imgEffect>
@@ -9488,14 +9476,14 @@
           </p:nvSpPr>
           <p:spPr>
             <a:xfrm>
-              <a:off x="4458476" y="1152218"/>
+              <a:off x="3779026" y="1074748"/>
               <a:ext cx="900000" cy="900000"/>
             </a:xfrm>
             <a:prstGeom prst="rect">
               <a:avLst/>
             </a:prstGeom>
             <a:blipFill>
-              <a:blip r:embed="rId5">
+              <a:blip r:embed="rId4">
                 <a:duotone>
                   <a:schemeClr val="bg2">
                     <a:shade val="45000"/>
@@ -9506,7 +9494,7 @@
                 <a:extLst>
                   <a:ext uri="{BEBA8EAE-BF5A-486C-A8C5-ECC9F3942E4B}">
                     <a14:imgProps xmlns:a14="http://schemas.microsoft.com/office/drawing/2010/main">
-                      <a14:imgLayer r:embed="rId6">
+                      <a14:imgLayer r:embed="rId5">
                         <a14:imgEffect>
                           <a14:artisticWatercolorSponge/>
                         </a14:imgEffect>
@@ -9596,14 +9584,14 @@
           </p:nvSpPr>
           <p:spPr>
             <a:xfrm>
-              <a:off x="2378071" y="2213139"/>
+              <a:off x="1698621" y="2135669"/>
               <a:ext cx="900000" cy="900000"/>
             </a:xfrm>
             <a:prstGeom prst="rect">
               <a:avLst/>
             </a:prstGeom>
             <a:blipFill>
-              <a:blip r:embed="rId5">
+              <a:blip r:embed="rId4">
                 <a:duotone>
                   <a:schemeClr val="bg2">
                     <a:shade val="45000"/>
@@ -9614,7 +9602,7 @@
                 <a:extLst>
                   <a:ext uri="{BEBA8EAE-BF5A-486C-A8C5-ECC9F3942E4B}">
                     <a14:imgProps xmlns:a14="http://schemas.microsoft.com/office/drawing/2010/main">
-                      <a14:imgLayer r:embed="rId6">
+                      <a14:imgLayer r:embed="rId5">
                         <a14:imgEffect>
                           <a14:artisticWatercolorSponge/>
                         </a14:imgEffect>
@@ -9704,14 +9692,14 @@
           </p:nvSpPr>
           <p:spPr>
             <a:xfrm>
-              <a:off x="5500937" y="1152218"/>
+              <a:off x="4821487" y="1074748"/>
               <a:ext cx="900000" cy="900000"/>
             </a:xfrm>
             <a:prstGeom prst="rect">
               <a:avLst/>
             </a:prstGeom>
             <a:blipFill>
-              <a:blip r:embed="rId5">
+              <a:blip r:embed="rId4">
                 <a:duotone>
                   <a:schemeClr val="bg2">
                     <a:shade val="45000"/>
@@ -9722,7 +9710,7 @@
                 <a:extLst>
                   <a:ext uri="{BEBA8EAE-BF5A-486C-A8C5-ECC9F3942E4B}">
                     <a14:imgProps xmlns:a14="http://schemas.microsoft.com/office/drawing/2010/main">
-                      <a14:imgLayer r:embed="rId6">
+                      <a14:imgLayer r:embed="rId5">
                         <a14:imgEffect>
                           <a14:artisticWatercolorSponge/>
                         </a14:imgEffect>
@@ -9812,14 +9800,14 @@
           </p:nvSpPr>
           <p:spPr>
             <a:xfrm>
-              <a:off x="5500937" y="2213139"/>
+              <a:off x="4821487" y="2135669"/>
               <a:ext cx="900000" cy="900000"/>
             </a:xfrm>
             <a:prstGeom prst="rect">
               <a:avLst/>
             </a:prstGeom>
             <a:blipFill>
-              <a:blip r:embed="rId5">
+              <a:blip r:embed="rId4">
                 <a:duotone>
                   <a:schemeClr val="bg2">
                     <a:shade val="45000"/>
@@ -9830,7 +9818,7 @@
                 <a:extLst>
                   <a:ext uri="{BEBA8EAE-BF5A-486C-A8C5-ECC9F3942E4B}">
                     <a14:imgProps xmlns:a14="http://schemas.microsoft.com/office/drawing/2010/main">
-                      <a14:imgLayer r:embed="rId6">
+                      <a14:imgLayer r:embed="rId5">
                         <a14:imgEffect>
                           <a14:artisticWatercolorSponge/>
                         </a14:imgEffect>
@@ -9920,14 +9908,14 @@
           </p:nvSpPr>
           <p:spPr>
             <a:xfrm>
-              <a:off x="2378071" y="3253320"/>
+              <a:off x="1698621" y="3175850"/>
               <a:ext cx="900000" cy="900000"/>
             </a:xfrm>
             <a:prstGeom prst="rect">
               <a:avLst/>
             </a:prstGeom>
             <a:blipFill>
-              <a:blip r:embed="rId5">
+              <a:blip r:embed="rId4">
                 <a:duotone>
                   <a:schemeClr val="bg2">
                     <a:shade val="45000"/>
@@ -9938,7 +9926,7 @@
                 <a:extLst>
                   <a:ext uri="{BEBA8EAE-BF5A-486C-A8C5-ECC9F3942E4B}">
                     <a14:imgProps xmlns:a14="http://schemas.microsoft.com/office/drawing/2010/main">
-                      <a14:imgLayer r:embed="rId6">
+                      <a14:imgLayer r:embed="rId5">
                         <a14:imgEffect>
                           <a14:artisticWatercolorSponge/>
                         </a14:imgEffect>
@@ -10028,14 +10016,14 @@
           </p:nvSpPr>
           <p:spPr>
             <a:xfrm>
-              <a:off x="3416015" y="3253320"/>
+              <a:off x="2736565" y="3175850"/>
               <a:ext cx="900000" cy="900000"/>
             </a:xfrm>
             <a:prstGeom prst="rect">
               <a:avLst/>
             </a:prstGeom>
             <a:blipFill>
-              <a:blip r:embed="rId5">
+              <a:blip r:embed="rId4">
                 <a:duotone>
                   <a:schemeClr val="bg2">
                     <a:shade val="45000"/>
@@ -10046,7 +10034,7 @@
                 <a:extLst>
                   <a:ext uri="{BEBA8EAE-BF5A-486C-A8C5-ECC9F3942E4B}">
                     <a14:imgProps xmlns:a14="http://schemas.microsoft.com/office/drawing/2010/main">
-                      <a14:imgLayer r:embed="rId6">
+                      <a14:imgLayer r:embed="rId5">
                         <a14:imgEffect>
                           <a14:artisticWatercolorSponge/>
                         </a14:imgEffect>
@@ -10136,14 +10124,14 @@
           </p:nvSpPr>
           <p:spPr>
             <a:xfrm>
-              <a:off x="5500937" y="3253320"/>
+              <a:off x="4821487" y="3175850"/>
               <a:ext cx="900000" cy="900000"/>
             </a:xfrm>
             <a:prstGeom prst="rect">
               <a:avLst/>
             </a:prstGeom>
             <a:blipFill>
-              <a:blip r:embed="rId5">
+              <a:blip r:embed="rId4">
                 <a:duotone>
                   <a:schemeClr val="bg2">
                     <a:shade val="45000"/>
@@ -10154,7 +10142,7 @@
                 <a:extLst>
                   <a:ext uri="{BEBA8EAE-BF5A-486C-A8C5-ECC9F3942E4B}">
                     <a14:imgProps xmlns:a14="http://schemas.microsoft.com/office/drawing/2010/main">
-                      <a14:imgLayer r:embed="rId6">
+                      <a14:imgLayer r:embed="rId5">
                         <a14:imgEffect>
                           <a14:artisticWatercolorSponge/>
                         </a14:imgEffect>
@@ -10244,14 +10232,14 @@
           </p:nvSpPr>
           <p:spPr>
             <a:xfrm>
-              <a:off x="4458476" y="3253320"/>
+              <a:off x="3779026" y="3175850"/>
               <a:ext cx="900000" cy="900000"/>
             </a:xfrm>
             <a:prstGeom prst="rect">
               <a:avLst/>
             </a:prstGeom>
             <a:blipFill>
-              <a:blip r:embed="rId5">
+              <a:blip r:embed="rId4">
                 <a:duotone>
                   <a:schemeClr val="bg2">
                     <a:shade val="45000"/>
@@ -10262,7 +10250,7 @@
                 <a:extLst>
                   <a:ext uri="{BEBA8EAE-BF5A-486C-A8C5-ECC9F3942E4B}">
                     <a14:imgProps xmlns:a14="http://schemas.microsoft.com/office/drawing/2010/main">
-                      <a14:imgLayer r:embed="rId6">
+                      <a14:imgLayer r:embed="rId5">
                         <a14:imgEffect>
                           <a14:artisticWatercolorSponge/>
                         </a14:imgEffect>
@@ -10356,7 +10344,7 @@
           </p:nvCxnSpPr>
           <p:spPr>
             <a:xfrm>
-              <a:off x="3278071" y="1602218"/>
+              <a:off x="2598621" y="1524748"/>
               <a:ext cx="137944" cy="0"/>
             </a:xfrm>
             <a:prstGeom prst="straightConnector1">
@@ -10364,7 +10352,7 @@
             </a:prstGeom>
             <a:ln w="19050">
               <a:solidFill>
-                <a:schemeClr val="tx1"/>
+                <a:schemeClr val="bg1"/>
               </a:solidFill>
             </a:ln>
           </p:spPr>
@@ -10401,7 +10389,7 @@
           </p:nvCxnSpPr>
           <p:spPr>
             <a:xfrm>
-              <a:off x="4316015" y="1602218"/>
+              <a:off x="3636565" y="1524748"/>
               <a:ext cx="142461" cy="0"/>
             </a:xfrm>
             <a:prstGeom prst="straightConnector1">
@@ -10409,7 +10397,7 @@
             </a:prstGeom>
             <a:ln w="19050">
               <a:solidFill>
-                <a:schemeClr val="tx1"/>
+                <a:schemeClr val="bg1"/>
               </a:solidFill>
             </a:ln>
           </p:spPr>
@@ -10446,7 +10434,7 @@
           </p:nvCxnSpPr>
           <p:spPr>
             <a:xfrm>
-              <a:off x="5358476" y="1602218"/>
+              <a:off x="4679026" y="1524748"/>
               <a:ext cx="142461" cy="0"/>
             </a:xfrm>
             <a:prstGeom prst="straightConnector1">
@@ -10454,7 +10442,7 @@
             </a:prstGeom>
             <a:ln w="19050">
               <a:solidFill>
-                <a:schemeClr val="tx1"/>
+                <a:schemeClr val="bg1"/>
               </a:solidFill>
             </a:ln>
           </p:spPr>
@@ -10491,7 +10479,7 @@
           </p:nvCxnSpPr>
           <p:spPr>
             <a:xfrm>
-              <a:off x="5950937" y="2052218"/>
+              <a:off x="5271487" y="1974748"/>
               <a:ext cx="0" cy="160921"/>
             </a:xfrm>
             <a:prstGeom prst="straightConnector1">
@@ -10499,7 +10487,7 @@
             </a:prstGeom>
             <a:ln w="19050">
               <a:solidFill>
-                <a:schemeClr val="tx1"/>
+                <a:schemeClr val="bg1"/>
               </a:solidFill>
             </a:ln>
           </p:spPr>
@@ -10536,7 +10524,7 @@
           </p:nvCxnSpPr>
           <p:spPr>
             <a:xfrm>
-              <a:off x="5950937" y="3113139"/>
+              <a:off x="5271487" y="3035669"/>
               <a:ext cx="0" cy="140181"/>
             </a:xfrm>
             <a:prstGeom prst="straightConnector1">
@@ -10544,7 +10532,7 @@
             </a:prstGeom>
             <a:ln w="19050">
               <a:solidFill>
-                <a:schemeClr val="tx1"/>
+                <a:schemeClr val="bg1"/>
               </a:solidFill>
             </a:ln>
           </p:spPr>
@@ -10581,7 +10569,7 @@
           </p:nvCxnSpPr>
           <p:spPr>
             <a:xfrm>
-              <a:off x="2828071" y="3113139"/>
+              <a:off x="2148621" y="3035669"/>
               <a:ext cx="0" cy="140181"/>
             </a:xfrm>
             <a:prstGeom prst="straightConnector1">
@@ -10589,7 +10577,7 @@
             </a:prstGeom>
             <a:ln w="19050">
               <a:solidFill>
-                <a:schemeClr val="tx1"/>
+                <a:schemeClr val="bg1"/>
               </a:solidFill>
             </a:ln>
           </p:spPr>
@@ -10626,7 +10614,7 @@
           </p:nvCxnSpPr>
           <p:spPr>
             <a:xfrm>
-              <a:off x="3278071" y="3703320"/>
+              <a:off x="2598621" y="3625850"/>
               <a:ext cx="137944" cy="0"/>
             </a:xfrm>
             <a:prstGeom prst="straightConnector1">
@@ -10634,7 +10622,7 @@
             </a:prstGeom>
             <a:ln w="19050">
               <a:solidFill>
-                <a:schemeClr val="tx1"/>
+                <a:schemeClr val="bg1"/>
               </a:solidFill>
             </a:ln>
           </p:spPr>
@@ -10671,7 +10659,7 @@
           </p:nvCxnSpPr>
           <p:spPr>
             <a:xfrm>
-              <a:off x="4316015" y="3703320"/>
+              <a:off x="3636565" y="3625850"/>
               <a:ext cx="142461" cy="0"/>
             </a:xfrm>
             <a:prstGeom prst="straightConnector1">
@@ -10679,7 +10667,7 @@
             </a:prstGeom>
             <a:ln w="19050">
               <a:solidFill>
-                <a:schemeClr val="tx1"/>
+                <a:schemeClr val="bg1"/>
               </a:solidFill>
             </a:ln>
           </p:spPr>
@@ -10716,7 +10704,7 @@
           </p:nvCxnSpPr>
           <p:spPr>
             <a:xfrm>
-              <a:off x="5358476" y="3703320"/>
+              <a:off x="4679026" y="3625850"/>
               <a:ext cx="142461" cy="0"/>
             </a:xfrm>
             <a:prstGeom prst="straightConnector1">
@@ -10724,7 +10712,7 @@
             </a:prstGeom>
             <a:ln w="19050">
               <a:solidFill>
-                <a:schemeClr val="tx1"/>
+                <a:schemeClr val="bg1"/>
               </a:solidFill>
             </a:ln>
           </p:spPr>
@@ -10757,7 +10745,7 @@
           </p:nvSpPr>
           <p:spPr>
             <a:xfrm>
-              <a:off x="3451860" y="2188454"/>
+              <a:off x="2772410" y="2110984"/>
               <a:ext cx="1870769" cy="830997"/>
             </a:xfrm>
             <a:prstGeom prst="rect">
@@ -10777,10 +10765,20 @@
                   <a:solidFill>
                     <a:schemeClr val="bg1"/>
                   </a:solidFill>
+                  <a:latin typeface="Lucida Calligraphy" panose="03010101010101010101" pitchFamily="66" charset="0"/>
+                  <a:cs typeface="Segoe UI" panose="020B0502040204020203" pitchFamily="34" charset="0"/>
+                </a:rPr>
+                <a:t>Q</a:t>
+              </a:r>
+              <a:r>
+                <a:rPr lang="fr-FR" sz="2400" dirty="0">
+                  <a:solidFill>
+                    <a:schemeClr val="bg1"/>
+                  </a:solidFill>
                   <a:latin typeface="Segoe UI" panose="020B0502040204020203" pitchFamily="34" charset="0"/>
                   <a:cs typeface="Segoe UI" panose="020B0502040204020203" pitchFamily="34" charset="0"/>
                 </a:rPr>
-                <a:t>Quartiers de</a:t>
+                <a:t>uartiers de</a:t>
               </a:r>
               <a:br>
                 <a:rPr lang="fr-FR" sz="2400" dirty="0">
@@ -10796,14 +10794,1854 @@
                   <a:solidFill>
                     <a:schemeClr val="bg1"/>
                   </a:solidFill>
+                  <a:latin typeface="Lucida Calligraphy" panose="03010101010101010101" pitchFamily="66" charset="0"/>
+                  <a:cs typeface="Segoe UI" panose="020B0502040204020203" pitchFamily="34" charset="0"/>
+                </a:rPr>
+                <a:t>G</a:t>
+              </a:r>
+              <a:r>
+                <a:rPr lang="fr-FR" sz="2400" dirty="0">
+                  <a:solidFill>
+                    <a:schemeClr val="bg1"/>
+                  </a:solidFill>
                   <a:latin typeface="Segoe UI" panose="020B0502040204020203" pitchFamily="34" charset="0"/>
                   <a:cs typeface="Segoe UI" panose="020B0502040204020203" pitchFamily="34" charset="0"/>
                 </a:rPr>
-                <a:t>Garde</a:t>
+                <a:t>arde</a:t>
               </a:r>
             </a:p>
           </p:txBody>
         </p:sp>
+        <p:grpSp>
+          <p:nvGrpSpPr>
+            <p:cNvPr id="38" name="Groupe 37">
+              <a:extLst>
+                <a:ext uri="{FF2B5EF4-FFF2-40B4-BE49-F238E27FC236}">
+                  <a16:creationId xmlns:a16="http://schemas.microsoft.com/office/drawing/2014/main" id="{78C503D4-C5FE-E283-528B-1CB2CA4F9440}"/>
+                </a:ext>
+              </a:extLst>
+            </p:cNvPr>
+            <p:cNvGrpSpPr/>
+            <p:nvPr/>
+          </p:nvGrpSpPr>
+          <p:grpSpPr>
+            <a:xfrm>
+              <a:off x="1962788" y="1370858"/>
+              <a:ext cx="365900" cy="340921"/>
+              <a:chOff x="1980005" y="1399967"/>
+              <a:chExt cx="365900" cy="340921"/>
+            </a:xfrm>
+          </p:grpSpPr>
+          <p:sp>
+            <p:nvSpPr>
+              <p:cNvPr id="20" name="Ellipse 19">
+                <a:extLst>
+                  <a:ext uri="{FF2B5EF4-FFF2-40B4-BE49-F238E27FC236}">
+                    <a16:creationId xmlns:a16="http://schemas.microsoft.com/office/drawing/2014/main" id="{711D637E-5D0E-F0D1-7DBC-3E53246301F6}"/>
+                  </a:ext>
+                </a:extLst>
+              </p:cNvPr>
+              <p:cNvSpPr>
+                <a:spLocks noChangeAspect="1"/>
+              </p:cNvSpPr>
+              <p:nvPr/>
+            </p:nvSpPr>
+            <p:spPr>
+              <a:xfrm>
+                <a:off x="1980005" y="1560888"/>
+                <a:ext cx="180000" cy="180000"/>
+              </a:xfrm>
+              <a:prstGeom prst="ellipse">
+                <a:avLst/>
+              </a:prstGeom>
+              <a:noFill/>
+              <a:ln>
+                <a:solidFill>
+                  <a:schemeClr val="tx1"/>
+                </a:solidFill>
+              </a:ln>
+            </p:spPr>
+            <p:style>
+              <a:lnRef idx="2">
+                <a:schemeClr val="accent1">
+                  <a:shade val="15000"/>
+                </a:schemeClr>
+              </a:lnRef>
+              <a:fillRef idx="1">
+                <a:schemeClr val="accent1"/>
+              </a:fillRef>
+              <a:effectRef idx="0">
+                <a:schemeClr val="accent1"/>
+              </a:effectRef>
+              <a:fontRef idx="minor">
+                <a:schemeClr val="lt1"/>
+              </a:fontRef>
+            </p:style>
+            <p:txBody>
+              <a:bodyPr rtlCol="0" anchor="ctr"/>
+              <a:lstStyle/>
+              <a:p>
+                <a:pPr algn="ctr"/>
+                <a:endParaRPr lang="fr-FR"/>
+              </a:p>
+            </p:txBody>
+          </p:sp>
+          <p:sp>
+            <p:nvSpPr>
+              <p:cNvPr id="27" name="Ellipse 26">
+                <a:extLst>
+                  <a:ext uri="{FF2B5EF4-FFF2-40B4-BE49-F238E27FC236}">
+                    <a16:creationId xmlns:a16="http://schemas.microsoft.com/office/drawing/2014/main" id="{570ED113-729F-640B-E135-A43D8C8A3605}"/>
+                  </a:ext>
+                </a:extLst>
+              </p:cNvPr>
+              <p:cNvSpPr>
+                <a:spLocks noChangeAspect="1"/>
+              </p:cNvSpPr>
+              <p:nvPr/>
+            </p:nvSpPr>
+            <p:spPr>
+              <a:xfrm>
+                <a:off x="2070005" y="1399967"/>
+                <a:ext cx="180000" cy="180000"/>
+              </a:xfrm>
+              <a:prstGeom prst="ellipse">
+                <a:avLst/>
+              </a:prstGeom>
+              <a:noFill/>
+              <a:ln>
+                <a:solidFill>
+                  <a:schemeClr val="tx1"/>
+                </a:solidFill>
+              </a:ln>
+            </p:spPr>
+            <p:style>
+              <a:lnRef idx="2">
+                <a:schemeClr val="accent1">
+                  <a:shade val="15000"/>
+                </a:schemeClr>
+              </a:lnRef>
+              <a:fillRef idx="1">
+                <a:schemeClr val="accent1"/>
+              </a:fillRef>
+              <a:effectRef idx="0">
+                <a:schemeClr val="accent1"/>
+              </a:effectRef>
+              <a:fontRef idx="minor">
+                <a:schemeClr val="lt1"/>
+              </a:fontRef>
+            </p:style>
+            <p:txBody>
+              <a:bodyPr rtlCol="0" anchor="ctr"/>
+              <a:lstStyle/>
+              <a:p>
+                <a:pPr algn="ctr"/>
+                <a:endParaRPr lang="fr-FR"/>
+              </a:p>
+            </p:txBody>
+          </p:sp>
+          <p:sp>
+            <p:nvSpPr>
+              <p:cNvPr id="37" name="Ellipse 36">
+                <a:extLst>
+                  <a:ext uri="{FF2B5EF4-FFF2-40B4-BE49-F238E27FC236}">
+                    <a16:creationId xmlns:a16="http://schemas.microsoft.com/office/drawing/2014/main" id="{A4181044-83AE-420E-1E58-9A5B9AC14EDB}"/>
+                  </a:ext>
+                </a:extLst>
+              </p:cNvPr>
+              <p:cNvSpPr>
+                <a:spLocks noChangeAspect="1"/>
+              </p:cNvSpPr>
+              <p:nvPr/>
+            </p:nvSpPr>
+            <p:spPr>
+              <a:xfrm>
+                <a:off x="2165905" y="1560888"/>
+                <a:ext cx="180000" cy="180000"/>
+              </a:xfrm>
+              <a:prstGeom prst="ellipse">
+                <a:avLst/>
+              </a:prstGeom>
+              <a:noFill/>
+              <a:ln>
+                <a:solidFill>
+                  <a:schemeClr val="tx1"/>
+                </a:solidFill>
+              </a:ln>
+            </p:spPr>
+            <p:style>
+              <a:lnRef idx="2">
+                <a:schemeClr val="accent1">
+                  <a:shade val="15000"/>
+                </a:schemeClr>
+              </a:lnRef>
+              <a:fillRef idx="1">
+                <a:schemeClr val="accent1"/>
+              </a:fillRef>
+              <a:effectRef idx="0">
+                <a:schemeClr val="accent1"/>
+              </a:effectRef>
+              <a:fontRef idx="minor">
+                <a:schemeClr val="lt1"/>
+              </a:fontRef>
+            </p:style>
+            <p:txBody>
+              <a:bodyPr rtlCol="0" anchor="ctr"/>
+              <a:lstStyle/>
+              <a:p>
+                <a:pPr algn="ctr"/>
+                <a:endParaRPr lang="fr-FR" dirty="0"/>
+              </a:p>
+            </p:txBody>
+          </p:sp>
+        </p:grpSp>
+        <p:grpSp>
+          <p:nvGrpSpPr>
+            <p:cNvPr id="39" name="Groupe 38">
+              <a:extLst>
+                <a:ext uri="{FF2B5EF4-FFF2-40B4-BE49-F238E27FC236}">
+                  <a16:creationId xmlns:a16="http://schemas.microsoft.com/office/drawing/2014/main" id="{BBAC0A87-D06C-341D-46B8-0417A761976E}"/>
+                </a:ext>
+              </a:extLst>
+            </p:cNvPr>
+            <p:cNvGrpSpPr/>
+            <p:nvPr/>
+          </p:nvGrpSpPr>
+          <p:grpSpPr>
+            <a:xfrm>
+              <a:off x="3001921" y="1370858"/>
+              <a:ext cx="365900" cy="340921"/>
+              <a:chOff x="1980005" y="1399967"/>
+              <a:chExt cx="365900" cy="340921"/>
+            </a:xfrm>
+          </p:grpSpPr>
+          <p:sp>
+            <p:nvSpPr>
+              <p:cNvPr id="40" name="Ellipse 39">
+                <a:extLst>
+                  <a:ext uri="{FF2B5EF4-FFF2-40B4-BE49-F238E27FC236}">
+                    <a16:creationId xmlns:a16="http://schemas.microsoft.com/office/drawing/2014/main" id="{783EC200-8C8C-95AF-52C5-FED330253137}"/>
+                  </a:ext>
+                </a:extLst>
+              </p:cNvPr>
+              <p:cNvSpPr>
+                <a:spLocks noChangeAspect="1"/>
+              </p:cNvSpPr>
+              <p:nvPr/>
+            </p:nvSpPr>
+            <p:spPr>
+              <a:xfrm>
+                <a:off x="1980005" y="1560888"/>
+                <a:ext cx="180000" cy="180000"/>
+              </a:xfrm>
+              <a:prstGeom prst="ellipse">
+                <a:avLst/>
+              </a:prstGeom>
+              <a:noFill/>
+              <a:ln>
+                <a:solidFill>
+                  <a:schemeClr val="tx1"/>
+                </a:solidFill>
+              </a:ln>
+            </p:spPr>
+            <p:style>
+              <a:lnRef idx="2">
+                <a:schemeClr val="accent1">
+                  <a:shade val="15000"/>
+                </a:schemeClr>
+              </a:lnRef>
+              <a:fillRef idx="1">
+                <a:schemeClr val="accent1"/>
+              </a:fillRef>
+              <a:effectRef idx="0">
+                <a:schemeClr val="accent1"/>
+              </a:effectRef>
+              <a:fontRef idx="minor">
+                <a:schemeClr val="lt1"/>
+              </a:fontRef>
+            </p:style>
+            <p:txBody>
+              <a:bodyPr rtlCol="0" anchor="ctr"/>
+              <a:lstStyle/>
+              <a:p>
+                <a:pPr algn="ctr"/>
+                <a:endParaRPr lang="fr-FR"/>
+              </a:p>
+            </p:txBody>
+          </p:sp>
+          <p:sp>
+            <p:nvSpPr>
+              <p:cNvPr id="41" name="Ellipse 40">
+                <a:extLst>
+                  <a:ext uri="{FF2B5EF4-FFF2-40B4-BE49-F238E27FC236}">
+                    <a16:creationId xmlns:a16="http://schemas.microsoft.com/office/drawing/2014/main" id="{196F1623-5A4B-8B84-0DFC-DCC642C0CA2A}"/>
+                  </a:ext>
+                </a:extLst>
+              </p:cNvPr>
+              <p:cNvSpPr>
+                <a:spLocks noChangeAspect="1"/>
+              </p:cNvSpPr>
+              <p:nvPr/>
+            </p:nvSpPr>
+            <p:spPr>
+              <a:xfrm>
+                <a:off x="2070005" y="1399967"/>
+                <a:ext cx="180000" cy="180000"/>
+              </a:xfrm>
+              <a:prstGeom prst="ellipse">
+                <a:avLst/>
+              </a:prstGeom>
+              <a:noFill/>
+              <a:ln>
+                <a:solidFill>
+                  <a:schemeClr val="tx1"/>
+                </a:solidFill>
+              </a:ln>
+            </p:spPr>
+            <p:style>
+              <a:lnRef idx="2">
+                <a:schemeClr val="accent1">
+                  <a:shade val="15000"/>
+                </a:schemeClr>
+              </a:lnRef>
+              <a:fillRef idx="1">
+                <a:schemeClr val="accent1"/>
+              </a:fillRef>
+              <a:effectRef idx="0">
+                <a:schemeClr val="accent1"/>
+              </a:effectRef>
+              <a:fontRef idx="minor">
+                <a:schemeClr val="lt1"/>
+              </a:fontRef>
+            </p:style>
+            <p:txBody>
+              <a:bodyPr rtlCol="0" anchor="ctr"/>
+              <a:lstStyle/>
+              <a:p>
+                <a:pPr algn="ctr"/>
+                <a:endParaRPr lang="fr-FR"/>
+              </a:p>
+            </p:txBody>
+          </p:sp>
+          <p:sp>
+            <p:nvSpPr>
+              <p:cNvPr id="42" name="Ellipse 41">
+                <a:extLst>
+                  <a:ext uri="{FF2B5EF4-FFF2-40B4-BE49-F238E27FC236}">
+                    <a16:creationId xmlns:a16="http://schemas.microsoft.com/office/drawing/2014/main" id="{3277EA15-1A19-5354-EF56-26E94F194A37}"/>
+                  </a:ext>
+                </a:extLst>
+              </p:cNvPr>
+              <p:cNvSpPr>
+                <a:spLocks noChangeAspect="1"/>
+              </p:cNvSpPr>
+              <p:nvPr/>
+            </p:nvSpPr>
+            <p:spPr>
+              <a:xfrm>
+                <a:off x="2165905" y="1560888"/>
+                <a:ext cx="180000" cy="180000"/>
+              </a:xfrm>
+              <a:prstGeom prst="ellipse">
+                <a:avLst/>
+              </a:prstGeom>
+              <a:noFill/>
+              <a:ln>
+                <a:solidFill>
+                  <a:schemeClr val="tx1"/>
+                </a:solidFill>
+              </a:ln>
+            </p:spPr>
+            <p:style>
+              <a:lnRef idx="2">
+                <a:schemeClr val="accent1">
+                  <a:shade val="15000"/>
+                </a:schemeClr>
+              </a:lnRef>
+              <a:fillRef idx="1">
+                <a:schemeClr val="accent1"/>
+              </a:fillRef>
+              <a:effectRef idx="0">
+                <a:schemeClr val="accent1"/>
+              </a:effectRef>
+              <a:fontRef idx="minor">
+                <a:schemeClr val="lt1"/>
+              </a:fontRef>
+            </p:style>
+            <p:txBody>
+              <a:bodyPr rtlCol="0" anchor="ctr"/>
+              <a:lstStyle/>
+              <a:p>
+                <a:pPr algn="ctr"/>
+                <a:endParaRPr lang="fr-FR" dirty="0"/>
+              </a:p>
+            </p:txBody>
+          </p:sp>
+        </p:grpSp>
+        <p:grpSp>
+          <p:nvGrpSpPr>
+            <p:cNvPr id="43" name="Groupe 42">
+              <a:extLst>
+                <a:ext uri="{FF2B5EF4-FFF2-40B4-BE49-F238E27FC236}">
+                  <a16:creationId xmlns:a16="http://schemas.microsoft.com/office/drawing/2014/main" id="{8447A651-6D35-9C01-F98A-EC9640E5EF7B}"/>
+                </a:ext>
+              </a:extLst>
+            </p:cNvPr>
+            <p:cNvGrpSpPr/>
+            <p:nvPr/>
+          </p:nvGrpSpPr>
+          <p:grpSpPr>
+            <a:xfrm>
+              <a:off x="4046076" y="1370858"/>
+              <a:ext cx="365900" cy="340921"/>
+              <a:chOff x="1980005" y="1399967"/>
+              <a:chExt cx="365900" cy="340921"/>
+            </a:xfrm>
+          </p:grpSpPr>
+          <p:sp>
+            <p:nvSpPr>
+              <p:cNvPr id="44" name="Ellipse 43">
+                <a:extLst>
+                  <a:ext uri="{FF2B5EF4-FFF2-40B4-BE49-F238E27FC236}">
+                    <a16:creationId xmlns:a16="http://schemas.microsoft.com/office/drawing/2014/main" id="{D578CB64-4B7A-752D-2959-C19E33D10870}"/>
+                  </a:ext>
+                </a:extLst>
+              </p:cNvPr>
+              <p:cNvSpPr>
+                <a:spLocks noChangeAspect="1"/>
+              </p:cNvSpPr>
+              <p:nvPr/>
+            </p:nvSpPr>
+            <p:spPr>
+              <a:xfrm>
+                <a:off x="1980005" y="1560888"/>
+                <a:ext cx="180000" cy="180000"/>
+              </a:xfrm>
+              <a:prstGeom prst="ellipse">
+                <a:avLst/>
+              </a:prstGeom>
+              <a:noFill/>
+              <a:ln>
+                <a:solidFill>
+                  <a:schemeClr val="tx1"/>
+                </a:solidFill>
+              </a:ln>
+            </p:spPr>
+            <p:style>
+              <a:lnRef idx="2">
+                <a:schemeClr val="accent1">
+                  <a:shade val="15000"/>
+                </a:schemeClr>
+              </a:lnRef>
+              <a:fillRef idx="1">
+                <a:schemeClr val="accent1"/>
+              </a:fillRef>
+              <a:effectRef idx="0">
+                <a:schemeClr val="accent1"/>
+              </a:effectRef>
+              <a:fontRef idx="minor">
+                <a:schemeClr val="lt1"/>
+              </a:fontRef>
+            </p:style>
+            <p:txBody>
+              <a:bodyPr rtlCol="0" anchor="ctr"/>
+              <a:lstStyle/>
+              <a:p>
+                <a:pPr algn="ctr"/>
+                <a:endParaRPr lang="fr-FR"/>
+              </a:p>
+            </p:txBody>
+          </p:sp>
+          <p:sp>
+            <p:nvSpPr>
+              <p:cNvPr id="45" name="Ellipse 44">
+                <a:extLst>
+                  <a:ext uri="{FF2B5EF4-FFF2-40B4-BE49-F238E27FC236}">
+                    <a16:creationId xmlns:a16="http://schemas.microsoft.com/office/drawing/2014/main" id="{ABBA66B3-E8FB-0532-BBE9-116E57F682F0}"/>
+                  </a:ext>
+                </a:extLst>
+              </p:cNvPr>
+              <p:cNvSpPr>
+                <a:spLocks noChangeAspect="1"/>
+              </p:cNvSpPr>
+              <p:nvPr/>
+            </p:nvSpPr>
+            <p:spPr>
+              <a:xfrm>
+                <a:off x="2070005" y="1399967"/>
+                <a:ext cx="180000" cy="180000"/>
+              </a:xfrm>
+              <a:prstGeom prst="ellipse">
+                <a:avLst/>
+              </a:prstGeom>
+              <a:noFill/>
+              <a:ln>
+                <a:solidFill>
+                  <a:schemeClr val="tx1"/>
+                </a:solidFill>
+              </a:ln>
+            </p:spPr>
+            <p:style>
+              <a:lnRef idx="2">
+                <a:schemeClr val="accent1">
+                  <a:shade val="15000"/>
+                </a:schemeClr>
+              </a:lnRef>
+              <a:fillRef idx="1">
+                <a:schemeClr val="accent1"/>
+              </a:fillRef>
+              <a:effectRef idx="0">
+                <a:schemeClr val="accent1"/>
+              </a:effectRef>
+              <a:fontRef idx="minor">
+                <a:schemeClr val="lt1"/>
+              </a:fontRef>
+            </p:style>
+            <p:txBody>
+              <a:bodyPr rtlCol="0" anchor="ctr"/>
+              <a:lstStyle/>
+              <a:p>
+                <a:pPr algn="ctr"/>
+                <a:endParaRPr lang="fr-FR" dirty="0"/>
+              </a:p>
+            </p:txBody>
+          </p:sp>
+          <p:sp>
+            <p:nvSpPr>
+              <p:cNvPr id="46" name="Ellipse 45">
+                <a:extLst>
+                  <a:ext uri="{FF2B5EF4-FFF2-40B4-BE49-F238E27FC236}">
+                    <a16:creationId xmlns:a16="http://schemas.microsoft.com/office/drawing/2014/main" id="{461325E2-541C-0148-2922-6CBE35C60EE2}"/>
+                  </a:ext>
+                </a:extLst>
+              </p:cNvPr>
+              <p:cNvSpPr>
+                <a:spLocks noChangeAspect="1"/>
+              </p:cNvSpPr>
+              <p:nvPr/>
+            </p:nvSpPr>
+            <p:spPr>
+              <a:xfrm>
+                <a:off x="2165905" y="1560888"/>
+                <a:ext cx="180000" cy="180000"/>
+              </a:xfrm>
+              <a:prstGeom prst="ellipse">
+                <a:avLst/>
+              </a:prstGeom>
+              <a:noFill/>
+              <a:ln>
+                <a:solidFill>
+                  <a:schemeClr val="tx1"/>
+                </a:solidFill>
+              </a:ln>
+            </p:spPr>
+            <p:style>
+              <a:lnRef idx="2">
+                <a:schemeClr val="accent1">
+                  <a:shade val="15000"/>
+                </a:schemeClr>
+              </a:lnRef>
+              <a:fillRef idx="1">
+                <a:schemeClr val="accent1"/>
+              </a:fillRef>
+              <a:effectRef idx="0">
+                <a:schemeClr val="accent1"/>
+              </a:effectRef>
+              <a:fontRef idx="minor">
+                <a:schemeClr val="lt1"/>
+              </a:fontRef>
+            </p:style>
+            <p:txBody>
+              <a:bodyPr rtlCol="0" anchor="ctr"/>
+              <a:lstStyle/>
+              <a:p>
+                <a:pPr algn="ctr"/>
+                <a:endParaRPr lang="fr-FR" dirty="0"/>
+              </a:p>
+            </p:txBody>
+          </p:sp>
+        </p:grpSp>
+        <p:grpSp>
+          <p:nvGrpSpPr>
+            <p:cNvPr id="47" name="Groupe 46">
+              <a:extLst>
+                <a:ext uri="{FF2B5EF4-FFF2-40B4-BE49-F238E27FC236}">
+                  <a16:creationId xmlns:a16="http://schemas.microsoft.com/office/drawing/2014/main" id="{A1530FA3-48D0-1E60-C78C-B6FDAEE2A825}"/>
+                </a:ext>
+              </a:extLst>
+            </p:cNvPr>
+            <p:cNvGrpSpPr/>
+            <p:nvPr/>
+          </p:nvGrpSpPr>
+          <p:grpSpPr>
+            <a:xfrm>
+              <a:off x="5084547" y="1370858"/>
+              <a:ext cx="365900" cy="340921"/>
+              <a:chOff x="1980005" y="1399967"/>
+              <a:chExt cx="365900" cy="340921"/>
+            </a:xfrm>
+          </p:grpSpPr>
+          <p:sp>
+            <p:nvSpPr>
+              <p:cNvPr id="48" name="Ellipse 47">
+                <a:extLst>
+                  <a:ext uri="{FF2B5EF4-FFF2-40B4-BE49-F238E27FC236}">
+                    <a16:creationId xmlns:a16="http://schemas.microsoft.com/office/drawing/2014/main" id="{C7615D04-830F-A108-B13F-907EC53D1E9D}"/>
+                  </a:ext>
+                </a:extLst>
+              </p:cNvPr>
+              <p:cNvSpPr>
+                <a:spLocks noChangeAspect="1"/>
+              </p:cNvSpPr>
+              <p:nvPr/>
+            </p:nvSpPr>
+            <p:spPr>
+              <a:xfrm>
+                <a:off x="1980005" y="1560888"/>
+                <a:ext cx="180000" cy="180000"/>
+              </a:xfrm>
+              <a:prstGeom prst="ellipse">
+                <a:avLst/>
+              </a:prstGeom>
+              <a:noFill/>
+              <a:ln>
+                <a:solidFill>
+                  <a:schemeClr val="tx1"/>
+                </a:solidFill>
+              </a:ln>
+            </p:spPr>
+            <p:style>
+              <a:lnRef idx="2">
+                <a:schemeClr val="accent1">
+                  <a:shade val="15000"/>
+                </a:schemeClr>
+              </a:lnRef>
+              <a:fillRef idx="1">
+                <a:schemeClr val="accent1"/>
+              </a:fillRef>
+              <a:effectRef idx="0">
+                <a:schemeClr val="accent1"/>
+              </a:effectRef>
+              <a:fontRef idx="minor">
+                <a:schemeClr val="lt1"/>
+              </a:fontRef>
+            </p:style>
+            <p:txBody>
+              <a:bodyPr rtlCol="0" anchor="ctr"/>
+              <a:lstStyle/>
+              <a:p>
+                <a:pPr algn="ctr"/>
+                <a:endParaRPr lang="fr-FR"/>
+              </a:p>
+            </p:txBody>
+          </p:sp>
+          <p:sp>
+            <p:nvSpPr>
+              <p:cNvPr id="49" name="Ellipse 48">
+                <a:extLst>
+                  <a:ext uri="{FF2B5EF4-FFF2-40B4-BE49-F238E27FC236}">
+                    <a16:creationId xmlns:a16="http://schemas.microsoft.com/office/drawing/2014/main" id="{EA9B2D18-64F9-1EEA-0FD1-6B87B5748E35}"/>
+                  </a:ext>
+                </a:extLst>
+              </p:cNvPr>
+              <p:cNvSpPr>
+                <a:spLocks noChangeAspect="1"/>
+              </p:cNvSpPr>
+              <p:nvPr/>
+            </p:nvSpPr>
+            <p:spPr>
+              <a:xfrm>
+                <a:off x="2070005" y="1399967"/>
+                <a:ext cx="180000" cy="180000"/>
+              </a:xfrm>
+              <a:prstGeom prst="ellipse">
+                <a:avLst/>
+              </a:prstGeom>
+              <a:noFill/>
+              <a:ln>
+                <a:solidFill>
+                  <a:schemeClr val="tx1"/>
+                </a:solidFill>
+              </a:ln>
+            </p:spPr>
+            <p:style>
+              <a:lnRef idx="2">
+                <a:schemeClr val="accent1">
+                  <a:shade val="15000"/>
+                </a:schemeClr>
+              </a:lnRef>
+              <a:fillRef idx="1">
+                <a:schemeClr val="accent1"/>
+              </a:fillRef>
+              <a:effectRef idx="0">
+                <a:schemeClr val="accent1"/>
+              </a:effectRef>
+              <a:fontRef idx="minor">
+                <a:schemeClr val="lt1"/>
+              </a:fontRef>
+            </p:style>
+            <p:txBody>
+              <a:bodyPr rtlCol="0" anchor="ctr"/>
+              <a:lstStyle/>
+              <a:p>
+                <a:pPr algn="ctr"/>
+                <a:endParaRPr lang="fr-FR"/>
+              </a:p>
+            </p:txBody>
+          </p:sp>
+          <p:sp>
+            <p:nvSpPr>
+              <p:cNvPr id="50" name="Ellipse 49">
+                <a:extLst>
+                  <a:ext uri="{FF2B5EF4-FFF2-40B4-BE49-F238E27FC236}">
+                    <a16:creationId xmlns:a16="http://schemas.microsoft.com/office/drawing/2014/main" id="{2FE9428D-3457-67E6-AF3C-6EF2156F5120}"/>
+                  </a:ext>
+                </a:extLst>
+              </p:cNvPr>
+              <p:cNvSpPr>
+                <a:spLocks noChangeAspect="1"/>
+              </p:cNvSpPr>
+              <p:nvPr/>
+            </p:nvSpPr>
+            <p:spPr>
+              <a:xfrm>
+                <a:off x="2165905" y="1560888"/>
+                <a:ext cx="180000" cy="180000"/>
+              </a:xfrm>
+              <a:prstGeom prst="ellipse">
+                <a:avLst/>
+              </a:prstGeom>
+              <a:noFill/>
+              <a:ln>
+                <a:solidFill>
+                  <a:schemeClr val="tx1"/>
+                </a:solidFill>
+              </a:ln>
+            </p:spPr>
+            <p:style>
+              <a:lnRef idx="2">
+                <a:schemeClr val="accent1">
+                  <a:shade val="15000"/>
+                </a:schemeClr>
+              </a:lnRef>
+              <a:fillRef idx="1">
+                <a:schemeClr val="accent1"/>
+              </a:fillRef>
+              <a:effectRef idx="0">
+                <a:schemeClr val="accent1"/>
+              </a:effectRef>
+              <a:fontRef idx="minor">
+                <a:schemeClr val="lt1"/>
+              </a:fontRef>
+            </p:style>
+            <p:txBody>
+              <a:bodyPr rtlCol="0" anchor="ctr"/>
+              <a:lstStyle/>
+              <a:p>
+                <a:pPr algn="ctr"/>
+                <a:endParaRPr lang="fr-FR" dirty="0"/>
+              </a:p>
+            </p:txBody>
+          </p:sp>
+        </p:grpSp>
+        <p:grpSp>
+          <p:nvGrpSpPr>
+            <p:cNvPr id="51" name="Groupe 50">
+              <a:extLst>
+                <a:ext uri="{FF2B5EF4-FFF2-40B4-BE49-F238E27FC236}">
+                  <a16:creationId xmlns:a16="http://schemas.microsoft.com/office/drawing/2014/main" id="{1A7BF680-7764-DFE9-4907-CA227D255E75}"/>
+                </a:ext>
+              </a:extLst>
+            </p:cNvPr>
+            <p:cNvGrpSpPr/>
+            <p:nvPr/>
+          </p:nvGrpSpPr>
+          <p:grpSpPr>
+            <a:xfrm>
+              <a:off x="5084547" y="2421087"/>
+              <a:ext cx="365900" cy="340921"/>
+              <a:chOff x="1980005" y="1399967"/>
+              <a:chExt cx="365900" cy="340921"/>
+            </a:xfrm>
+          </p:grpSpPr>
+          <p:sp>
+            <p:nvSpPr>
+              <p:cNvPr id="52" name="Ellipse 51">
+                <a:extLst>
+                  <a:ext uri="{FF2B5EF4-FFF2-40B4-BE49-F238E27FC236}">
+                    <a16:creationId xmlns:a16="http://schemas.microsoft.com/office/drawing/2014/main" id="{FE21FC1E-C5B5-2B47-698A-71720CD91095}"/>
+                  </a:ext>
+                </a:extLst>
+              </p:cNvPr>
+              <p:cNvSpPr>
+                <a:spLocks noChangeAspect="1"/>
+              </p:cNvSpPr>
+              <p:nvPr/>
+            </p:nvSpPr>
+            <p:spPr>
+              <a:xfrm>
+                <a:off x="1980005" y="1560888"/>
+                <a:ext cx="180000" cy="180000"/>
+              </a:xfrm>
+              <a:prstGeom prst="ellipse">
+                <a:avLst/>
+              </a:prstGeom>
+              <a:noFill/>
+              <a:ln>
+                <a:solidFill>
+                  <a:schemeClr val="tx1"/>
+                </a:solidFill>
+              </a:ln>
+            </p:spPr>
+            <p:style>
+              <a:lnRef idx="2">
+                <a:schemeClr val="accent1">
+                  <a:shade val="15000"/>
+                </a:schemeClr>
+              </a:lnRef>
+              <a:fillRef idx="1">
+                <a:schemeClr val="accent1"/>
+              </a:fillRef>
+              <a:effectRef idx="0">
+                <a:schemeClr val="accent1"/>
+              </a:effectRef>
+              <a:fontRef idx="minor">
+                <a:schemeClr val="lt1"/>
+              </a:fontRef>
+            </p:style>
+            <p:txBody>
+              <a:bodyPr rtlCol="0" anchor="ctr"/>
+              <a:lstStyle/>
+              <a:p>
+                <a:pPr algn="ctr"/>
+                <a:endParaRPr lang="fr-FR"/>
+              </a:p>
+            </p:txBody>
+          </p:sp>
+          <p:sp>
+            <p:nvSpPr>
+              <p:cNvPr id="53" name="Ellipse 52">
+                <a:extLst>
+                  <a:ext uri="{FF2B5EF4-FFF2-40B4-BE49-F238E27FC236}">
+                    <a16:creationId xmlns:a16="http://schemas.microsoft.com/office/drawing/2014/main" id="{0D60A342-8444-5B8B-E446-DD2FAC960081}"/>
+                  </a:ext>
+                </a:extLst>
+              </p:cNvPr>
+              <p:cNvSpPr>
+                <a:spLocks noChangeAspect="1"/>
+              </p:cNvSpPr>
+              <p:nvPr/>
+            </p:nvSpPr>
+            <p:spPr>
+              <a:xfrm>
+                <a:off x="2070005" y="1399967"/>
+                <a:ext cx="180000" cy="180000"/>
+              </a:xfrm>
+              <a:prstGeom prst="ellipse">
+                <a:avLst/>
+              </a:prstGeom>
+              <a:noFill/>
+              <a:ln>
+                <a:solidFill>
+                  <a:schemeClr val="tx1"/>
+                </a:solidFill>
+              </a:ln>
+            </p:spPr>
+            <p:style>
+              <a:lnRef idx="2">
+                <a:schemeClr val="accent1">
+                  <a:shade val="15000"/>
+                </a:schemeClr>
+              </a:lnRef>
+              <a:fillRef idx="1">
+                <a:schemeClr val="accent1"/>
+              </a:fillRef>
+              <a:effectRef idx="0">
+                <a:schemeClr val="accent1"/>
+              </a:effectRef>
+              <a:fontRef idx="minor">
+                <a:schemeClr val="lt1"/>
+              </a:fontRef>
+            </p:style>
+            <p:txBody>
+              <a:bodyPr rtlCol="0" anchor="ctr"/>
+              <a:lstStyle/>
+              <a:p>
+                <a:pPr algn="ctr"/>
+                <a:endParaRPr lang="fr-FR"/>
+              </a:p>
+            </p:txBody>
+          </p:sp>
+          <p:sp>
+            <p:nvSpPr>
+              <p:cNvPr id="54" name="Ellipse 53">
+                <a:extLst>
+                  <a:ext uri="{FF2B5EF4-FFF2-40B4-BE49-F238E27FC236}">
+                    <a16:creationId xmlns:a16="http://schemas.microsoft.com/office/drawing/2014/main" id="{E1BCD40A-BB1E-70A4-6E06-ADAB0AEB4B55}"/>
+                  </a:ext>
+                </a:extLst>
+              </p:cNvPr>
+              <p:cNvSpPr>
+                <a:spLocks noChangeAspect="1"/>
+              </p:cNvSpPr>
+              <p:nvPr/>
+            </p:nvSpPr>
+            <p:spPr>
+              <a:xfrm>
+                <a:off x="2165905" y="1560888"/>
+                <a:ext cx="180000" cy="180000"/>
+              </a:xfrm>
+              <a:prstGeom prst="ellipse">
+                <a:avLst/>
+              </a:prstGeom>
+              <a:noFill/>
+              <a:ln>
+                <a:solidFill>
+                  <a:schemeClr val="tx1"/>
+                </a:solidFill>
+              </a:ln>
+            </p:spPr>
+            <p:style>
+              <a:lnRef idx="2">
+                <a:schemeClr val="accent1">
+                  <a:shade val="15000"/>
+                </a:schemeClr>
+              </a:lnRef>
+              <a:fillRef idx="1">
+                <a:schemeClr val="accent1"/>
+              </a:fillRef>
+              <a:effectRef idx="0">
+                <a:schemeClr val="accent1"/>
+              </a:effectRef>
+              <a:fontRef idx="minor">
+                <a:schemeClr val="lt1"/>
+              </a:fontRef>
+            </p:style>
+            <p:txBody>
+              <a:bodyPr rtlCol="0" anchor="ctr"/>
+              <a:lstStyle/>
+              <a:p>
+                <a:pPr algn="ctr"/>
+                <a:endParaRPr lang="fr-FR" dirty="0"/>
+              </a:p>
+            </p:txBody>
+          </p:sp>
+        </p:grpSp>
+        <p:grpSp>
+          <p:nvGrpSpPr>
+            <p:cNvPr id="55" name="Groupe 54">
+              <a:extLst>
+                <a:ext uri="{FF2B5EF4-FFF2-40B4-BE49-F238E27FC236}">
+                  <a16:creationId xmlns:a16="http://schemas.microsoft.com/office/drawing/2014/main" id="{5004A93E-8A11-48B9-2B65-D7CDE0E55ED3}"/>
+                </a:ext>
+              </a:extLst>
+            </p:cNvPr>
+            <p:cNvGrpSpPr/>
+            <p:nvPr/>
+          </p:nvGrpSpPr>
+          <p:grpSpPr>
+            <a:xfrm>
+              <a:off x="5084547" y="3461489"/>
+              <a:ext cx="365900" cy="340921"/>
+              <a:chOff x="1980005" y="1399967"/>
+              <a:chExt cx="365900" cy="340921"/>
+            </a:xfrm>
+          </p:grpSpPr>
+          <p:sp>
+            <p:nvSpPr>
+              <p:cNvPr id="56" name="Ellipse 55">
+                <a:extLst>
+                  <a:ext uri="{FF2B5EF4-FFF2-40B4-BE49-F238E27FC236}">
+                    <a16:creationId xmlns:a16="http://schemas.microsoft.com/office/drawing/2014/main" id="{27D70036-2ED9-A1B2-53AC-102449BF3B5B}"/>
+                  </a:ext>
+                </a:extLst>
+              </p:cNvPr>
+              <p:cNvSpPr>
+                <a:spLocks noChangeAspect="1"/>
+              </p:cNvSpPr>
+              <p:nvPr/>
+            </p:nvSpPr>
+            <p:spPr>
+              <a:xfrm>
+                <a:off x="1980005" y="1560888"/>
+                <a:ext cx="180000" cy="180000"/>
+              </a:xfrm>
+              <a:prstGeom prst="ellipse">
+                <a:avLst/>
+              </a:prstGeom>
+              <a:noFill/>
+              <a:ln>
+                <a:solidFill>
+                  <a:schemeClr val="tx1"/>
+                </a:solidFill>
+              </a:ln>
+            </p:spPr>
+            <p:style>
+              <a:lnRef idx="2">
+                <a:schemeClr val="accent1">
+                  <a:shade val="15000"/>
+                </a:schemeClr>
+              </a:lnRef>
+              <a:fillRef idx="1">
+                <a:schemeClr val="accent1"/>
+              </a:fillRef>
+              <a:effectRef idx="0">
+                <a:schemeClr val="accent1"/>
+              </a:effectRef>
+              <a:fontRef idx="minor">
+                <a:schemeClr val="lt1"/>
+              </a:fontRef>
+            </p:style>
+            <p:txBody>
+              <a:bodyPr rtlCol="0" anchor="ctr"/>
+              <a:lstStyle/>
+              <a:p>
+                <a:pPr algn="ctr"/>
+                <a:endParaRPr lang="fr-FR"/>
+              </a:p>
+            </p:txBody>
+          </p:sp>
+          <p:sp>
+            <p:nvSpPr>
+              <p:cNvPr id="57" name="Ellipse 56">
+                <a:extLst>
+                  <a:ext uri="{FF2B5EF4-FFF2-40B4-BE49-F238E27FC236}">
+                    <a16:creationId xmlns:a16="http://schemas.microsoft.com/office/drawing/2014/main" id="{4BC29B43-F82D-13BC-CFBE-24340E164415}"/>
+                  </a:ext>
+                </a:extLst>
+              </p:cNvPr>
+              <p:cNvSpPr>
+                <a:spLocks noChangeAspect="1"/>
+              </p:cNvSpPr>
+              <p:nvPr/>
+            </p:nvSpPr>
+            <p:spPr>
+              <a:xfrm>
+                <a:off x="2070005" y="1399967"/>
+                <a:ext cx="180000" cy="180000"/>
+              </a:xfrm>
+              <a:prstGeom prst="ellipse">
+                <a:avLst/>
+              </a:prstGeom>
+              <a:noFill/>
+              <a:ln>
+                <a:solidFill>
+                  <a:schemeClr val="tx1"/>
+                </a:solidFill>
+              </a:ln>
+            </p:spPr>
+            <p:style>
+              <a:lnRef idx="2">
+                <a:schemeClr val="accent1">
+                  <a:shade val="15000"/>
+                </a:schemeClr>
+              </a:lnRef>
+              <a:fillRef idx="1">
+                <a:schemeClr val="accent1"/>
+              </a:fillRef>
+              <a:effectRef idx="0">
+                <a:schemeClr val="accent1"/>
+              </a:effectRef>
+              <a:fontRef idx="minor">
+                <a:schemeClr val="lt1"/>
+              </a:fontRef>
+            </p:style>
+            <p:txBody>
+              <a:bodyPr rtlCol="0" anchor="ctr"/>
+              <a:lstStyle/>
+              <a:p>
+                <a:pPr algn="ctr"/>
+                <a:endParaRPr lang="fr-FR"/>
+              </a:p>
+            </p:txBody>
+          </p:sp>
+          <p:sp>
+            <p:nvSpPr>
+              <p:cNvPr id="58" name="Ellipse 57">
+                <a:extLst>
+                  <a:ext uri="{FF2B5EF4-FFF2-40B4-BE49-F238E27FC236}">
+                    <a16:creationId xmlns:a16="http://schemas.microsoft.com/office/drawing/2014/main" id="{9536A47A-8555-5339-2590-1C13F76010F0}"/>
+                  </a:ext>
+                </a:extLst>
+              </p:cNvPr>
+              <p:cNvSpPr>
+                <a:spLocks noChangeAspect="1"/>
+              </p:cNvSpPr>
+              <p:nvPr/>
+            </p:nvSpPr>
+            <p:spPr>
+              <a:xfrm>
+                <a:off x="2165905" y="1560888"/>
+                <a:ext cx="180000" cy="180000"/>
+              </a:xfrm>
+              <a:prstGeom prst="ellipse">
+                <a:avLst/>
+              </a:prstGeom>
+              <a:noFill/>
+              <a:ln>
+                <a:solidFill>
+                  <a:schemeClr val="tx1"/>
+                </a:solidFill>
+              </a:ln>
+            </p:spPr>
+            <p:style>
+              <a:lnRef idx="2">
+                <a:schemeClr val="accent1">
+                  <a:shade val="15000"/>
+                </a:schemeClr>
+              </a:lnRef>
+              <a:fillRef idx="1">
+                <a:schemeClr val="accent1"/>
+              </a:fillRef>
+              <a:effectRef idx="0">
+                <a:schemeClr val="accent1"/>
+              </a:effectRef>
+              <a:fontRef idx="minor">
+                <a:schemeClr val="lt1"/>
+              </a:fontRef>
+            </p:style>
+            <p:txBody>
+              <a:bodyPr rtlCol="0" anchor="ctr"/>
+              <a:lstStyle/>
+              <a:p>
+                <a:pPr algn="ctr"/>
+                <a:endParaRPr lang="fr-FR" dirty="0"/>
+              </a:p>
+            </p:txBody>
+          </p:sp>
+        </p:grpSp>
+        <p:grpSp>
+          <p:nvGrpSpPr>
+            <p:cNvPr id="59" name="Groupe 58">
+              <a:extLst>
+                <a:ext uri="{FF2B5EF4-FFF2-40B4-BE49-F238E27FC236}">
+                  <a16:creationId xmlns:a16="http://schemas.microsoft.com/office/drawing/2014/main" id="{558513BF-3CC5-2AEB-D3CF-F6AE8BF9A9A1}"/>
+                </a:ext>
+              </a:extLst>
+            </p:cNvPr>
+            <p:cNvGrpSpPr/>
+            <p:nvPr/>
+          </p:nvGrpSpPr>
+          <p:grpSpPr>
+            <a:xfrm>
+              <a:off x="1962788" y="2421087"/>
+              <a:ext cx="365900" cy="340921"/>
+              <a:chOff x="1980005" y="1399967"/>
+              <a:chExt cx="365900" cy="340921"/>
+            </a:xfrm>
+          </p:grpSpPr>
+          <p:sp>
+            <p:nvSpPr>
+              <p:cNvPr id="60" name="Ellipse 59">
+                <a:extLst>
+                  <a:ext uri="{FF2B5EF4-FFF2-40B4-BE49-F238E27FC236}">
+                    <a16:creationId xmlns:a16="http://schemas.microsoft.com/office/drawing/2014/main" id="{F53E6423-C701-CDFF-945D-EB903BD9F3A5}"/>
+                  </a:ext>
+                </a:extLst>
+              </p:cNvPr>
+              <p:cNvSpPr>
+                <a:spLocks noChangeAspect="1"/>
+              </p:cNvSpPr>
+              <p:nvPr/>
+            </p:nvSpPr>
+            <p:spPr>
+              <a:xfrm>
+                <a:off x="1980005" y="1560888"/>
+                <a:ext cx="180000" cy="180000"/>
+              </a:xfrm>
+              <a:prstGeom prst="ellipse">
+                <a:avLst/>
+              </a:prstGeom>
+              <a:noFill/>
+              <a:ln>
+                <a:solidFill>
+                  <a:schemeClr val="tx1"/>
+                </a:solidFill>
+              </a:ln>
+            </p:spPr>
+            <p:style>
+              <a:lnRef idx="2">
+                <a:schemeClr val="accent1">
+                  <a:shade val="15000"/>
+                </a:schemeClr>
+              </a:lnRef>
+              <a:fillRef idx="1">
+                <a:schemeClr val="accent1"/>
+              </a:fillRef>
+              <a:effectRef idx="0">
+                <a:schemeClr val="accent1"/>
+              </a:effectRef>
+              <a:fontRef idx="minor">
+                <a:schemeClr val="lt1"/>
+              </a:fontRef>
+            </p:style>
+            <p:txBody>
+              <a:bodyPr rtlCol="0" anchor="ctr"/>
+              <a:lstStyle/>
+              <a:p>
+                <a:pPr algn="ctr"/>
+                <a:endParaRPr lang="fr-FR"/>
+              </a:p>
+            </p:txBody>
+          </p:sp>
+          <p:sp>
+            <p:nvSpPr>
+              <p:cNvPr id="61" name="Ellipse 60">
+                <a:extLst>
+                  <a:ext uri="{FF2B5EF4-FFF2-40B4-BE49-F238E27FC236}">
+                    <a16:creationId xmlns:a16="http://schemas.microsoft.com/office/drawing/2014/main" id="{5F7D9414-A808-41F9-D72E-806D72751B6B}"/>
+                  </a:ext>
+                </a:extLst>
+              </p:cNvPr>
+              <p:cNvSpPr>
+                <a:spLocks noChangeAspect="1"/>
+              </p:cNvSpPr>
+              <p:nvPr/>
+            </p:nvSpPr>
+            <p:spPr>
+              <a:xfrm>
+                <a:off x="2070005" y="1399967"/>
+                <a:ext cx="180000" cy="180000"/>
+              </a:xfrm>
+              <a:prstGeom prst="ellipse">
+                <a:avLst/>
+              </a:prstGeom>
+              <a:noFill/>
+              <a:ln>
+                <a:solidFill>
+                  <a:schemeClr val="tx1"/>
+                </a:solidFill>
+              </a:ln>
+            </p:spPr>
+            <p:style>
+              <a:lnRef idx="2">
+                <a:schemeClr val="accent1">
+                  <a:shade val="15000"/>
+                </a:schemeClr>
+              </a:lnRef>
+              <a:fillRef idx="1">
+                <a:schemeClr val="accent1"/>
+              </a:fillRef>
+              <a:effectRef idx="0">
+                <a:schemeClr val="accent1"/>
+              </a:effectRef>
+              <a:fontRef idx="minor">
+                <a:schemeClr val="lt1"/>
+              </a:fontRef>
+            </p:style>
+            <p:txBody>
+              <a:bodyPr rtlCol="0" anchor="ctr"/>
+              <a:lstStyle/>
+              <a:p>
+                <a:pPr algn="ctr"/>
+                <a:endParaRPr lang="fr-FR"/>
+              </a:p>
+            </p:txBody>
+          </p:sp>
+          <p:sp>
+            <p:nvSpPr>
+              <p:cNvPr id="62" name="Ellipse 61">
+                <a:extLst>
+                  <a:ext uri="{FF2B5EF4-FFF2-40B4-BE49-F238E27FC236}">
+                    <a16:creationId xmlns:a16="http://schemas.microsoft.com/office/drawing/2014/main" id="{9F2A85B2-75DB-B48D-4256-2DC5382F52FD}"/>
+                  </a:ext>
+                </a:extLst>
+              </p:cNvPr>
+              <p:cNvSpPr>
+                <a:spLocks noChangeAspect="1"/>
+              </p:cNvSpPr>
+              <p:nvPr/>
+            </p:nvSpPr>
+            <p:spPr>
+              <a:xfrm>
+                <a:off x="2165905" y="1560888"/>
+                <a:ext cx="180000" cy="180000"/>
+              </a:xfrm>
+              <a:prstGeom prst="ellipse">
+                <a:avLst/>
+              </a:prstGeom>
+              <a:noFill/>
+              <a:ln>
+                <a:solidFill>
+                  <a:schemeClr val="tx1"/>
+                </a:solidFill>
+              </a:ln>
+            </p:spPr>
+            <p:style>
+              <a:lnRef idx="2">
+                <a:schemeClr val="accent1">
+                  <a:shade val="15000"/>
+                </a:schemeClr>
+              </a:lnRef>
+              <a:fillRef idx="1">
+                <a:schemeClr val="accent1"/>
+              </a:fillRef>
+              <a:effectRef idx="0">
+                <a:schemeClr val="accent1"/>
+              </a:effectRef>
+              <a:fontRef idx="minor">
+                <a:schemeClr val="lt1"/>
+              </a:fontRef>
+            </p:style>
+            <p:txBody>
+              <a:bodyPr rtlCol="0" anchor="ctr"/>
+              <a:lstStyle/>
+              <a:p>
+                <a:pPr algn="ctr"/>
+                <a:endParaRPr lang="fr-FR" dirty="0"/>
+              </a:p>
+            </p:txBody>
+          </p:sp>
+        </p:grpSp>
+        <p:grpSp>
+          <p:nvGrpSpPr>
+            <p:cNvPr id="63" name="Groupe 62">
+              <a:extLst>
+                <a:ext uri="{FF2B5EF4-FFF2-40B4-BE49-F238E27FC236}">
+                  <a16:creationId xmlns:a16="http://schemas.microsoft.com/office/drawing/2014/main" id="{DA18EA87-7120-4612-A6F9-4FD03FE27967}"/>
+                </a:ext>
+              </a:extLst>
+            </p:cNvPr>
+            <p:cNvGrpSpPr/>
+            <p:nvPr/>
+          </p:nvGrpSpPr>
+          <p:grpSpPr>
+            <a:xfrm>
+              <a:off x="1962788" y="3461489"/>
+              <a:ext cx="365900" cy="340921"/>
+              <a:chOff x="1980005" y="1399967"/>
+              <a:chExt cx="365900" cy="340921"/>
+            </a:xfrm>
+          </p:grpSpPr>
+          <p:sp>
+            <p:nvSpPr>
+              <p:cNvPr id="64" name="Ellipse 63">
+                <a:extLst>
+                  <a:ext uri="{FF2B5EF4-FFF2-40B4-BE49-F238E27FC236}">
+                    <a16:creationId xmlns:a16="http://schemas.microsoft.com/office/drawing/2014/main" id="{C850CEF2-A9A7-0DCB-A4BA-AD8D69D72CC0}"/>
+                  </a:ext>
+                </a:extLst>
+              </p:cNvPr>
+              <p:cNvSpPr>
+                <a:spLocks noChangeAspect="1"/>
+              </p:cNvSpPr>
+              <p:nvPr/>
+            </p:nvSpPr>
+            <p:spPr>
+              <a:xfrm>
+                <a:off x="1980005" y="1560888"/>
+                <a:ext cx="180000" cy="180000"/>
+              </a:xfrm>
+              <a:prstGeom prst="ellipse">
+                <a:avLst/>
+              </a:prstGeom>
+              <a:noFill/>
+              <a:ln>
+                <a:solidFill>
+                  <a:schemeClr val="tx1"/>
+                </a:solidFill>
+              </a:ln>
+            </p:spPr>
+            <p:style>
+              <a:lnRef idx="2">
+                <a:schemeClr val="accent1">
+                  <a:shade val="15000"/>
+                </a:schemeClr>
+              </a:lnRef>
+              <a:fillRef idx="1">
+                <a:schemeClr val="accent1"/>
+              </a:fillRef>
+              <a:effectRef idx="0">
+                <a:schemeClr val="accent1"/>
+              </a:effectRef>
+              <a:fontRef idx="minor">
+                <a:schemeClr val="lt1"/>
+              </a:fontRef>
+            </p:style>
+            <p:txBody>
+              <a:bodyPr rtlCol="0" anchor="ctr"/>
+              <a:lstStyle/>
+              <a:p>
+                <a:pPr algn="ctr"/>
+                <a:endParaRPr lang="fr-FR"/>
+              </a:p>
+            </p:txBody>
+          </p:sp>
+          <p:sp>
+            <p:nvSpPr>
+              <p:cNvPr id="65" name="Ellipse 64">
+                <a:extLst>
+                  <a:ext uri="{FF2B5EF4-FFF2-40B4-BE49-F238E27FC236}">
+                    <a16:creationId xmlns:a16="http://schemas.microsoft.com/office/drawing/2014/main" id="{929808E7-AAAA-B225-5635-D8CE742F2173}"/>
+                  </a:ext>
+                </a:extLst>
+              </p:cNvPr>
+              <p:cNvSpPr>
+                <a:spLocks noChangeAspect="1"/>
+              </p:cNvSpPr>
+              <p:nvPr/>
+            </p:nvSpPr>
+            <p:spPr>
+              <a:xfrm>
+                <a:off x="2070005" y="1399967"/>
+                <a:ext cx="180000" cy="180000"/>
+              </a:xfrm>
+              <a:prstGeom prst="ellipse">
+                <a:avLst/>
+              </a:prstGeom>
+              <a:noFill/>
+              <a:ln>
+                <a:solidFill>
+                  <a:schemeClr val="tx1"/>
+                </a:solidFill>
+              </a:ln>
+            </p:spPr>
+            <p:style>
+              <a:lnRef idx="2">
+                <a:schemeClr val="accent1">
+                  <a:shade val="15000"/>
+                </a:schemeClr>
+              </a:lnRef>
+              <a:fillRef idx="1">
+                <a:schemeClr val="accent1"/>
+              </a:fillRef>
+              <a:effectRef idx="0">
+                <a:schemeClr val="accent1"/>
+              </a:effectRef>
+              <a:fontRef idx="minor">
+                <a:schemeClr val="lt1"/>
+              </a:fontRef>
+            </p:style>
+            <p:txBody>
+              <a:bodyPr rtlCol="0" anchor="ctr"/>
+              <a:lstStyle/>
+              <a:p>
+                <a:pPr algn="ctr"/>
+                <a:endParaRPr lang="fr-FR"/>
+              </a:p>
+            </p:txBody>
+          </p:sp>
+          <p:sp>
+            <p:nvSpPr>
+              <p:cNvPr id="66" name="Ellipse 65">
+                <a:extLst>
+                  <a:ext uri="{FF2B5EF4-FFF2-40B4-BE49-F238E27FC236}">
+                    <a16:creationId xmlns:a16="http://schemas.microsoft.com/office/drawing/2014/main" id="{D6543C29-6DD2-560B-2B28-0F71220FAC63}"/>
+                  </a:ext>
+                </a:extLst>
+              </p:cNvPr>
+              <p:cNvSpPr>
+                <a:spLocks noChangeAspect="1"/>
+              </p:cNvSpPr>
+              <p:nvPr/>
+            </p:nvSpPr>
+            <p:spPr>
+              <a:xfrm>
+                <a:off x="2165905" y="1560888"/>
+                <a:ext cx="180000" cy="180000"/>
+              </a:xfrm>
+              <a:prstGeom prst="ellipse">
+                <a:avLst/>
+              </a:prstGeom>
+              <a:noFill/>
+              <a:ln>
+                <a:solidFill>
+                  <a:schemeClr val="tx1"/>
+                </a:solidFill>
+              </a:ln>
+            </p:spPr>
+            <p:style>
+              <a:lnRef idx="2">
+                <a:schemeClr val="accent1">
+                  <a:shade val="15000"/>
+                </a:schemeClr>
+              </a:lnRef>
+              <a:fillRef idx="1">
+                <a:schemeClr val="accent1"/>
+              </a:fillRef>
+              <a:effectRef idx="0">
+                <a:schemeClr val="accent1"/>
+              </a:effectRef>
+              <a:fontRef idx="minor">
+                <a:schemeClr val="lt1"/>
+              </a:fontRef>
+            </p:style>
+            <p:txBody>
+              <a:bodyPr rtlCol="0" anchor="ctr"/>
+              <a:lstStyle/>
+              <a:p>
+                <a:pPr algn="ctr"/>
+                <a:endParaRPr lang="fr-FR" dirty="0"/>
+              </a:p>
+            </p:txBody>
+          </p:sp>
+        </p:grpSp>
+        <p:grpSp>
+          <p:nvGrpSpPr>
+            <p:cNvPr id="71" name="Groupe 70">
+              <a:extLst>
+                <a:ext uri="{FF2B5EF4-FFF2-40B4-BE49-F238E27FC236}">
+                  <a16:creationId xmlns:a16="http://schemas.microsoft.com/office/drawing/2014/main" id="{4A45DCC2-A06B-74CB-782C-F37D46171E7F}"/>
+                </a:ext>
+              </a:extLst>
+            </p:cNvPr>
+            <p:cNvGrpSpPr/>
+            <p:nvPr/>
+          </p:nvGrpSpPr>
+          <p:grpSpPr>
+            <a:xfrm>
+              <a:off x="3016485" y="3461489"/>
+              <a:ext cx="365900" cy="340921"/>
+              <a:chOff x="1980005" y="1399967"/>
+              <a:chExt cx="365900" cy="340921"/>
+            </a:xfrm>
+          </p:grpSpPr>
+          <p:sp>
+            <p:nvSpPr>
+              <p:cNvPr id="72" name="Ellipse 71">
+                <a:extLst>
+                  <a:ext uri="{FF2B5EF4-FFF2-40B4-BE49-F238E27FC236}">
+                    <a16:creationId xmlns:a16="http://schemas.microsoft.com/office/drawing/2014/main" id="{7C17EACB-7BA6-5ACB-B5BD-E6A854094645}"/>
+                  </a:ext>
+                </a:extLst>
+              </p:cNvPr>
+              <p:cNvSpPr>
+                <a:spLocks noChangeAspect="1"/>
+              </p:cNvSpPr>
+              <p:nvPr/>
+            </p:nvSpPr>
+            <p:spPr>
+              <a:xfrm>
+                <a:off x="1980005" y="1560888"/>
+                <a:ext cx="180000" cy="180000"/>
+              </a:xfrm>
+              <a:prstGeom prst="ellipse">
+                <a:avLst/>
+              </a:prstGeom>
+              <a:noFill/>
+              <a:ln>
+                <a:solidFill>
+                  <a:schemeClr val="tx1"/>
+                </a:solidFill>
+              </a:ln>
+            </p:spPr>
+            <p:style>
+              <a:lnRef idx="2">
+                <a:schemeClr val="accent1">
+                  <a:shade val="15000"/>
+                </a:schemeClr>
+              </a:lnRef>
+              <a:fillRef idx="1">
+                <a:schemeClr val="accent1"/>
+              </a:fillRef>
+              <a:effectRef idx="0">
+                <a:schemeClr val="accent1"/>
+              </a:effectRef>
+              <a:fontRef idx="minor">
+                <a:schemeClr val="lt1"/>
+              </a:fontRef>
+            </p:style>
+            <p:txBody>
+              <a:bodyPr rtlCol="0" anchor="ctr"/>
+              <a:lstStyle/>
+              <a:p>
+                <a:pPr algn="ctr"/>
+                <a:endParaRPr lang="fr-FR"/>
+              </a:p>
+            </p:txBody>
+          </p:sp>
+          <p:sp>
+            <p:nvSpPr>
+              <p:cNvPr id="73" name="Ellipse 72">
+                <a:extLst>
+                  <a:ext uri="{FF2B5EF4-FFF2-40B4-BE49-F238E27FC236}">
+                    <a16:creationId xmlns:a16="http://schemas.microsoft.com/office/drawing/2014/main" id="{549DE83E-43FB-9EE4-3A8A-5C511F45510C}"/>
+                  </a:ext>
+                </a:extLst>
+              </p:cNvPr>
+              <p:cNvSpPr>
+                <a:spLocks noChangeAspect="1"/>
+              </p:cNvSpPr>
+              <p:nvPr/>
+            </p:nvSpPr>
+            <p:spPr>
+              <a:xfrm>
+                <a:off x="2070005" y="1399967"/>
+                <a:ext cx="180000" cy="180000"/>
+              </a:xfrm>
+              <a:prstGeom prst="ellipse">
+                <a:avLst/>
+              </a:prstGeom>
+              <a:noFill/>
+              <a:ln>
+                <a:solidFill>
+                  <a:schemeClr val="tx1"/>
+                </a:solidFill>
+              </a:ln>
+            </p:spPr>
+            <p:style>
+              <a:lnRef idx="2">
+                <a:schemeClr val="accent1">
+                  <a:shade val="15000"/>
+                </a:schemeClr>
+              </a:lnRef>
+              <a:fillRef idx="1">
+                <a:schemeClr val="accent1"/>
+              </a:fillRef>
+              <a:effectRef idx="0">
+                <a:schemeClr val="accent1"/>
+              </a:effectRef>
+              <a:fontRef idx="minor">
+                <a:schemeClr val="lt1"/>
+              </a:fontRef>
+            </p:style>
+            <p:txBody>
+              <a:bodyPr rtlCol="0" anchor="ctr"/>
+              <a:lstStyle/>
+              <a:p>
+                <a:pPr algn="ctr"/>
+                <a:endParaRPr lang="fr-FR"/>
+              </a:p>
+            </p:txBody>
+          </p:sp>
+          <p:sp>
+            <p:nvSpPr>
+              <p:cNvPr id="74" name="Ellipse 73">
+                <a:extLst>
+                  <a:ext uri="{FF2B5EF4-FFF2-40B4-BE49-F238E27FC236}">
+                    <a16:creationId xmlns:a16="http://schemas.microsoft.com/office/drawing/2014/main" id="{E3289CBB-6C56-18A9-EF24-754D9F6E69A4}"/>
+                  </a:ext>
+                </a:extLst>
+              </p:cNvPr>
+              <p:cNvSpPr>
+                <a:spLocks noChangeAspect="1"/>
+              </p:cNvSpPr>
+              <p:nvPr/>
+            </p:nvSpPr>
+            <p:spPr>
+              <a:xfrm>
+                <a:off x="2165905" y="1560888"/>
+                <a:ext cx="180000" cy="180000"/>
+              </a:xfrm>
+              <a:prstGeom prst="ellipse">
+                <a:avLst/>
+              </a:prstGeom>
+              <a:noFill/>
+              <a:ln>
+                <a:solidFill>
+                  <a:schemeClr val="tx1"/>
+                </a:solidFill>
+              </a:ln>
+            </p:spPr>
+            <p:style>
+              <a:lnRef idx="2">
+                <a:schemeClr val="accent1">
+                  <a:shade val="15000"/>
+                </a:schemeClr>
+              </a:lnRef>
+              <a:fillRef idx="1">
+                <a:schemeClr val="accent1"/>
+              </a:fillRef>
+              <a:effectRef idx="0">
+                <a:schemeClr val="accent1"/>
+              </a:effectRef>
+              <a:fontRef idx="minor">
+                <a:schemeClr val="lt1"/>
+              </a:fontRef>
+            </p:style>
+            <p:txBody>
+              <a:bodyPr rtlCol="0" anchor="ctr"/>
+              <a:lstStyle/>
+              <a:p>
+                <a:pPr algn="ctr"/>
+                <a:endParaRPr lang="fr-FR" dirty="0"/>
+              </a:p>
+            </p:txBody>
+          </p:sp>
+        </p:grpSp>
+        <p:grpSp>
+          <p:nvGrpSpPr>
+            <p:cNvPr id="75" name="Groupe 74">
+              <a:extLst>
+                <a:ext uri="{FF2B5EF4-FFF2-40B4-BE49-F238E27FC236}">
+                  <a16:creationId xmlns:a16="http://schemas.microsoft.com/office/drawing/2014/main" id="{05993991-5222-05B6-A881-9178A31E23F3}"/>
+                </a:ext>
+              </a:extLst>
+            </p:cNvPr>
+            <p:cNvGrpSpPr/>
+            <p:nvPr/>
+          </p:nvGrpSpPr>
+          <p:grpSpPr>
+            <a:xfrm>
+              <a:off x="4043126" y="3461489"/>
+              <a:ext cx="365900" cy="340921"/>
+              <a:chOff x="1980005" y="1399967"/>
+              <a:chExt cx="365900" cy="340921"/>
+            </a:xfrm>
+          </p:grpSpPr>
+          <p:sp>
+            <p:nvSpPr>
+              <p:cNvPr id="76" name="Ellipse 75">
+                <a:extLst>
+                  <a:ext uri="{FF2B5EF4-FFF2-40B4-BE49-F238E27FC236}">
+                    <a16:creationId xmlns:a16="http://schemas.microsoft.com/office/drawing/2014/main" id="{1FC3C45E-2835-103B-C27C-198D4D80432D}"/>
+                  </a:ext>
+                </a:extLst>
+              </p:cNvPr>
+              <p:cNvSpPr>
+                <a:spLocks noChangeAspect="1"/>
+              </p:cNvSpPr>
+              <p:nvPr/>
+            </p:nvSpPr>
+            <p:spPr>
+              <a:xfrm>
+                <a:off x="1980005" y="1560888"/>
+                <a:ext cx="180000" cy="180000"/>
+              </a:xfrm>
+              <a:prstGeom prst="ellipse">
+                <a:avLst/>
+              </a:prstGeom>
+              <a:noFill/>
+              <a:ln>
+                <a:solidFill>
+                  <a:schemeClr val="tx1"/>
+                </a:solidFill>
+              </a:ln>
+            </p:spPr>
+            <p:style>
+              <a:lnRef idx="2">
+                <a:schemeClr val="accent1">
+                  <a:shade val="15000"/>
+                </a:schemeClr>
+              </a:lnRef>
+              <a:fillRef idx="1">
+                <a:schemeClr val="accent1"/>
+              </a:fillRef>
+              <a:effectRef idx="0">
+                <a:schemeClr val="accent1"/>
+              </a:effectRef>
+              <a:fontRef idx="minor">
+                <a:schemeClr val="lt1"/>
+              </a:fontRef>
+            </p:style>
+            <p:txBody>
+              <a:bodyPr rtlCol="0" anchor="ctr"/>
+              <a:lstStyle/>
+              <a:p>
+                <a:pPr algn="ctr"/>
+                <a:endParaRPr lang="fr-FR"/>
+              </a:p>
+            </p:txBody>
+          </p:sp>
+          <p:sp>
+            <p:nvSpPr>
+              <p:cNvPr id="77" name="Ellipse 76">
+                <a:extLst>
+                  <a:ext uri="{FF2B5EF4-FFF2-40B4-BE49-F238E27FC236}">
+                    <a16:creationId xmlns:a16="http://schemas.microsoft.com/office/drawing/2014/main" id="{6C3BE214-5EB7-58C6-E461-CC9CB830655D}"/>
+                  </a:ext>
+                </a:extLst>
+              </p:cNvPr>
+              <p:cNvSpPr>
+                <a:spLocks noChangeAspect="1"/>
+              </p:cNvSpPr>
+              <p:nvPr/>
+            </p:nvSpPr>
+            <p:spPr>
+              <a:xfrm>
+                <a:off x="2070005" y="1399967"/>
+                <a:ext cx="180000" cy="180000"/>
+              </a:xfrm>
+              <a:prstGeom prst="ellipse">
+                <a:avLst/>
+              </a:prstGeom>
+              <a:noFill/>
+              <a:ln>
+                <a:solidFill>
+                  <a:schemeClr val="tx1"/>
+                </a:solidFill>
+              </a:ln>
+            </p:spPr>
+            <p:style>
+              <a:lnRef idx="2">
+                <a:schemeClr val="accent1">
+                  <a:shade val="15000"/>
+                </a:schemeClr>
+              </a:lnRef>
+              <a:fillRef idx="1">
+                <a:schemeClr val="accent1"/>
+              </a:fillRef>
+              <a:effectRef idx="0">
+                <a:schemeClr val="accent1"/>
+              </a:effectRef>
+              <a:fontRef idx="minor">
+                <a:schemeClr val="lt1"/>
+              </a:fontRef>
+            </p:style>
+            <p:txBody>
+              <a:bodyPr rtlCol="0" anchor="ctr"/>
+              <a:lstStyle/>
+              <a:p>
+                <a:pPr algn="ctr"/>
+                <a:endParaRPr lang="fr-FR"/>
+              </a:p>
+            </p:txBody>
+          </p:sp>
+          <p:sp>
+            <p:nvSpPr>
+              <p:cNvPr id="78" name="Ellipse 77">
+                <a:extLst>
+                  <a:ext uri="{FF2B5EF4-FFF2-40B4-BE49-F238E27FC236}">
+                    <a16:creationId xmlns:a16="http://schemas.microsoft.com/office/drawing/2014/main" id="{EC2A7A86-2B04-9235-545A-47E6A4C42762}"/>
+                  </a:ext>
+                </a:extLst>
+              </p:cNvPr>
+              <p:cNvSpPr>
+                <a:spLocks noChangeAspect="1"/>
+              </p:cNvSpPr>
+              <p:nvPr/>
+            </p:nvSpPr>
+            <p:spPr>
+              <a:xfrm>
+                <a:off x="2165905" y="1560888"/>
+                <a:ext cx="180000" cy="180000"/>
+              </a:xfrm>
+              <a:prstGeom prst="ellipse">
+                <a:avLst/>
+              </a:prstGeom>
+              <a:noFill/>
+              <a:ln>
+                <a:solidFill>
+                  <a:schemeClr val="tx1"/>
+                </a:solidFill>
+              </a:ln>
+            </p:spPr>
+            <p:style>
+              <a:lnRef idx="2">
+                <a:schemeClr val="accent1">
+                  <a:shade val="15000"/>
+                </a:schemeClr>
+              </a:lnRef>
+              <a:fillRef idx="1">
+                <a:schemeClr val="accent1"/>
+              </a:fillRef>
+              <a:effectRef idx="0">
+                <a:schemeClr val="accent1"/>
+              </a:effectRef>
+              <a:fontRef idx="minor">
+                <a:schemeClr val="lt1"/>
+              </a:fontRef>
+            </p:style>
+            <p:txBody>
+              <a:bodyPr rtlCol="0" anchor="ctr"/>
+              <a:lstStyle/>
+              <a:p>
+                <a:pPr algn="ctr"/>
+                <a:endParaRPr lang="fr-FR" dirty="0"/>
+              </a:p>
+            </p:txBody>
+          </p:sp>
+        </p:grpSp>
       </p:grpSp>
     </p:spTree>
     <p:extLst>

</xml_diff>